<commit_message>
Fact-check corrections: Cursor now has hooks, headless CLI, native parallel agents
Updated the Claude-Cursor comparison everywhere (deck slide 7, both
guides, mapping doc) to 2026 reality: near feature parity; the split
decision now rests on automation economics (~5.5x token efficiency,
per-pipeline API billing vs credits), guard maturity, first-party
GitHub integration, and our proven playbook. Added section 8 to both
guides: the full Sentry -> Linear -> PR loop with exact wiring points.
</commit_message>
<xml_diff>
--- a/slides/ai-first-development.pptx
+++ b/slides/ai-first-development.pptx
@@ -1127,7 +1127,7 @@
           <a:p>
             <a:r>
               <a:rPr lang="en-US" dirty="0"/>
-              <a:t>نفس المفاهيم بأسماء مختلفة — والفجوتين الحاسمتين: الحراس الصارمين (hooks) والتشغيل بلا واجهة عالسيرفر — الاثنين عند Claude. عشان هيك: Cursor للشغل اليومي جوا المحرر، وClaude للأتمتة والبوابات. مش منافسة — تكامل، وMCP مشترك.</a:t>
+              <a:t>بـ 2026 الأداتين وصلوا شبه تكافؤ — Cursor ضاف hooks وCLI وتوازي أصلي. قرارنا مش 'مين بيقدر' — الاثنين بيقدروا. القرار بالاقتصاديات (~5.5x توكنز أقل لنفس المهمة بمقارنات مستقلة + فوترة API شفافة لكل أنبوب مقابل credits)، بنضج الحراس (تبعت Claude مجربة وعنا شغالة)، بالتكامل الرسمي مع GitHub، وبإنه كل الـ playbook تبعنا مبني ومجرب على Claude. وCursor بيظل ملك المحرر — تكامل مش منافسة.</a:t>
             </a:r>
             <a:endParaRPr lang="en-US" dirty="0"/>
           </a:p>
@@ -7554,7 +7554,7 @@
                           <a:ea typeface="Calibri" pitchFamily="34" charset="-122"/>
                           <a:cs typeface="Calibri" pitchFamily="34" charset="-120"/>
                         </a:rPr>
-                        <a:t>.cursor/rules</a:t>
+                        <a:t>.cursor/rules — parity</a:t>
                       </a:r>
                       <a:endParaRPr lang="en-US" sz="1200" dirty="0">
                         <a:latin typeface="Calibri" charset="0"/>
@@ -7621,7 +7621,7 @@
                           <a:ea typeface="Calibri" pitchFamily="34" charset="-122"/>
                           <a:cs typeface="Calibri" pitchFamily="34" charset="-120"/>
                         </a:rPr>
-                        <a:t>Permissions</a:t>
+                        <a:t>Guards (hooks)</a:t>
                       </a:r>
                       <a:endParaRPr lang="en-US" sz="1200" dirty="0">
                         <a:latin typeface="Calibri" charset="0"/>
@@ -7689,7 +7689,7 @@
                           <a:ea typeface="Calibri" pitchFamily="34" charset="-122"/>
                           <a:cs typeface="Calibri" pitchFamily="34" charset="-120"/>
                         </a:rPr>
-                        <a:t>allow / ask / deny lists</a:t>
+                        <a:t>GA, battle-tested — proven in our setup</a:t>
                       </a:r>
                       <a:endParaRPr lang="en-US" sz="1200" dirty="0">
                         <a:latin typeface="Calibri" charset="0"/>
@@ -7757,7 +7757,7 @@
                           <a:ea typeface="Calibri" pitchFamily="34" charset="-122"/>
                           <a:cs typeface="Calibri" pitchFamily="34" charset="-120"/>
                         </a:rPr>
-                        <a:t>Agent auto-run settings</a:t>
+                        <a:t>Yes since late 2025 — months old</a:t>
                       </a:r>
                       <a:endParaRPr lang="en-US" sz="1200" dirty="0">
                         <a:latin typeface="Calibri" charset="0"/>
@@ -7827,7 +7827,7 @@
                           <a:ea typeface="Calibri" pitchFamily="34" charset="-122"/>
                           <a:cs typeface="Calibri" pitchFamily="34" charset="-120"/>
                         </a:rPr>
-                        <a:t>Hard guards (hooks)</a:t>
+                        <a:t>Parallel agents</a:t>
                       </a:r>
                       <a:endParaRPr lang="en-US" sz="1200" dirty="0">
                         <a:latin typeface="Calibri" charset="0"/>
@@ -7892,7 +7892,7 @@
                           <a:ea typeface="Calibri" pitchFamily="34" charset="-122"/>
                           <a:cs typeface="Calibri" pitchFamily="34" charset="-120"/>
                         </a:rPr>
-                        <a:t>Yes — block before execution</a:t>
+                        <a:t>Native + orchestrator procedures</a:t>
                       </a:r>
                       <a:endParaRPr lang="en-US" sz="1200" dirty="0">
                         <a:latin typeface="Calibri" charset="0"/>
@@ -7957,7 +7957,7 @@
                           <a:ea typeface="Calibri" pitchFamily="34" charset="-122"/>
                           <a:cs typeface="Calibri" pitchFamily="34" charset="-120"/>
                         </a:rPr>
-                        <a:t>No full equivalent</a:t>
+                        <a:t>Native since 2.0 — worktrees, /multitask</a:t>
                       </a:r>
                       <a:endParaRPr lang="en-US" sz="1200" dirty="0">
                         <a:latin typeface="Calibri" charset="0"/>
@@ -8024,7 +8024,7 @@
                           <a:ea typeface="Calibri" pitchFamily="34" charset="-122"/>
                           <a:cs typeface="Calibri" pitchFamily="34" charset="-120"/>
                         </a:rPr>
-                        <a:t>Parallel work</a:t>
+                        <a:t>Skills / procedures</a:t>
                       </a:r>
                       <a:endParaRPr lang="en-US" sz="1200" dirty="0">
                         <a:latin typeface="Calibri" charset="0"/>
@@ -8092,7 +8092,7 @@
                           <a:ea typeface="Calibri" pitchFamily="34" charset="-122"/>
                           <a:cs typeface="Calibri" pitchFamily="34" charset="-120"/>
                         </a:rPr>
-                        <a:t>Parallel agents + worktrees</a:t>
+                        <a:t>SKILL.md</a:t>
                       </a:r>
                       <a:endParaRPr lang="en-US" sz="1200" dirty="0">
                         <a:latin typeface="Calibri" charset="0"/>
@@ -8160,7 +8160,7 @@
                           <a:ea typeface="Calibri" pitchFamily="34" charset="-122"/>
                           <a:cs typeface="Calibri" pitchFamily="34" charset="-120"/>
                         </a:rPr>
-                        <a:t>Background agents</a:t>
+                        <a:t>SKILL.md too — parity</a:t>
                       </a:r>
                       <a:endParaRPr lang="en-US" sz="1200" dirty="0">
                         <a:latin typeface="Calibri" charset="0"/>
@@ -8230,7 +8230,7 @@
                           <a:ea typeface="Calibri" pitchFamily="34" charset="-122"/>
                           <a:cs typeface="Calibri" pitchFamily="34" charset="-120"/>
                         </a:rPr>
-                        <a:t>External tools</a:t>
+                        <a:t>Headless / CI</a:t>
                       </a:r>
                       <a:endParaRPr lang="en-US" sz="1200" dirty="0">
                         <a:latin typeface="Calibri" charset="0"/>
@@ -8295,7 +8295,7 @@
                           <a:ea typeface="Calibri" pitchFamily="34" charset="-122"/>
                           <a:cs typeface="Calibri" pitchFamily="34" charset="-120"/>
                         </a:rPr>
-                        <a:t>MCP</a:t>
+                        <a:t>claude -p + first-party GitHub action</a:t>
                       </a:r>
                       <a:endParaRPr lang="en-US" sz="1200" dirty="0">
                         <a:latin typeface="Calibri" charset="0"/>
@@ -8360,7 +8360,7 @@
                           <a:ea typeface="Calibri" pitchFamily="34" charset="-122"/>
                           <a:cs typeface="Calibri" pitchFamily="34" charset="-120"/>
                         </a:rPr>
-                        <a:t>MCP — same protocol</a:t>
+                        <a:t>cursor-agent -p + community action</a:t>
                       </a:r>
                       <a:endParaRPr lang="en-US" sz="1200" dirty="0">
                         <a:latin typeface="Calibri" charset="0"/>
@@ -8406,212 +8406,6 @@
                       <a:headEnd type="none" w="med" len="med"/>
                       <a:tailEnd type="none" w="med" len="med"/>
                     </a:lnB>
-                  </a:tcPr>
-                </a:tc>
-              </a:tr>
-              <a:tr h="411480">
-                <a:tc>
-                  <a:txBody>
-                    <a:bodyPr/>
-                    <a:lstStyle/>
-                    <a:p>
-                      <a:pPr indent="0" marL="0">
-                        <a:buNone/>
-                      </a:pPr>
-                      <a:r>
-                        <a:rPr lang="en-US" sz="1200" dirty="0">
-                          <a:solidFill>
-                            <a:srgbClr val="212121"/>
-                          </a:solidFill>
-                          <a:latin typeface="Calibri" pitchFamily="34" charset="0"/>
-                          <a:ea typeface="Calibri" pitchFamily="34" charset="-122"/>
-                          <a:cs typeface="Calibri" pitchFamily="34" charset="-120"/>
-                        </a:rPr>
-                        <a:t>Headless / CI / server</a:t>
-                      </a:r>
-                      <a:endParaRPr lang="en-US" sz="1200" dirty="0">
-                        <a:latin typeface="Calibri" charset="0"/>
-                        <a:ea typeface="Calibri" charset="0"/>
-                        <a:cs typeface="Calibri" charset="0"/>
-                      </a:endParaRPr>
-                    </a:p>
-                  </a:txBody>
-                  <a:tcPr marL="91440" marR="91440" marT="45720" marB="45720" anchor="ctr">
-                    <a:lnL w="9525" cap="flat" cmpd="sng" algn="ctr">
-                      <a:solidFill>
-                        <a:srgbClr val="D9D9D9"/>
-                      </a:solidFill>
-                      <a:prstDash val="solid"/>
-                      <a:round/>
-                      <a:headEnd type="none" w="med" len="med"/>
-                      <a:tailEnd type="none" w="med" len="med"/>
-                    </a:lnL>
-                    <a:lnR w="9525" cap="flat" cmpd="sng" algn="ctr">
-                      <a:solidFill>
-                        <a:srgbClr val="D9D9D9"/>
-                      </a:solidFill>
-                      <a:prstDash val="solid"/>
-                      <a:round/>
-                      <a:headEnd type="none" w="med" len="med"/>
-                      <a:tailEnd type="none" w="med" len="med"/>
-                    </a:lnR>
-                    <a:lnT w="9525" cap="flat" cmpd="sng" algn="ctr">
-                      <a:solidFill>
-                        <a:srgbClr val="D9D9D9"/>
-                      </a:solidFill>
-                      <a:prstDash val="solid"/>
-                      <a:round/>
-                      <a:headEnd type="none" w="med" len="med"/>
-                      <a:tailEnd type="none" w="med" len="med"/>
-                    </a:lnT>
-                    <a:lnB w="9525" cap="flat" cmpd="sng" algn="ctr">
-                      <a:solidFill>
-                        <a:srgbClr val="D9D9D9"/>
-                      </a:solidFill>
-                      <a:prstDash val="solid"/>
-                      <a:round/>
-                      <a:headEnd type="none" w="med" len="med"/>
-                      <a:tailEnd type="none" w="med" len="med"/>
-                    </a:lnB>
-                    <a:solidFill>
-                      <a:srgbClr val="F2F2F2"/>
-                    </a:solidFill>
-                  </a:tcPr>
-                </a:tc>
-                <a:tc>
-                  <a:txBody>
-                    <a:bodyPr/>
-                    <a:lstStyle/>
-                    <a:p>
-                      <a:pPr indent="0" marL="0">
-                        <a:buNone/>
-                      </a:pPr>
-                      <a:r>
-                        <a:rPr lang="en-US" sz="1200" dirty="0">
-                          <a:solidFill>
-                            <a:srgbClr val="212121"/>
-                          </a:solidFill>
-                          <a:latin typeface="Calibri" pitchFamily="34" charset="0"/>
-                          <a:ea typeface="Calibri" pitchFamily="34" charset="-122"/>
-                          <a:cs typeface="Calibri" pitchFamily="34" charset="-120"/>
-                        </a:rPr>
-                        <a:t>claude -p + official GitHub Action</a:t>
-                      </a:r>
-                      <a:endParaRPr lang="en-US" sz="1200" dirty="0">
-                        <a:latin typeface="Calibri" charset="0"/>
-                        <a:ea typeface="Calibri" charset="0"/>
-                        <a:cs typeface="Calibri" charset="0"/>
-                      </a:endParaRPr>
-                    </a:p>
-                  </a:txBody>
-                  <a:tcPr marL="91440" marR="91440" marT="45720" marB="45720" anchor="ctr">
-                    <a:lnL w="9525" cap="flat" cmpd="sng" algn="ctr">
-                      <a:solidFill>
-                        <a:srgbClr val="D9D9D9"/>
-                      </a:solidFill>
-                      <a:prstDash val="solid"/>
-                      <a:round/>
-                      <a:headEnd type="none" w="med" len="med"/>
-                      <a:tailEnd type="none" w="med" len="med"/>
-                    </a:lnL>
-                    <a:lnR w="9525" cap="flat" cmpd="sng" algn="ctr">
-                      <a:solidFill>
-                        <a:srgbClr val="D9D9D9"/>
-                      </a:solidFill>
-                      <a:prstDash val="solid"/>
-                      <a:round/>
-                      <a:headEnd type="none" w="med" len="med"/>
-                      <a:tailEnd type="none" w="med" len="med"/>
-                    </a:lnR>
-                    <a:lnT w="9525" cap="flat" cmpd="sng" algn="ctr">
-                      <a:solidFill>
-                        <a:srgbClr val="D9D9D9"/>
-                      </a:solidFill>
-                      <a:prstDash val="solid"/>
-                      <a:round/>
-                      <a:headEnd type="none" w="med" len="med"/>
-                      <a:tailEnd type="none" w="med" len="med"/>
-                    </a:lnT>
-                    <a:lnB w="9525" cap="flat" cmpd="sng" algn="ctr">
-                      <a:solidFill>
-                        <a:srgbClr val="D9D9D9"/>
-                      </a:solidFill>
-                      <a:prstDash val="solid"/>
-                      <a:round/>
-                      <a:headEnd type="none" w="med" len="med"/>
-                      <a:tailEnd type="none" w="med" len="med"/>
-                    </a:lnB>
-                    <a:solidFill>
-                      <a:srgbClr val="F2F2F2"/>
-                    </a:solidFill>
-                  </a:tcPr>
-                </a:tc>
-                <a:tc>
-                  <a:txBody>
-                    <a:bodyPr/>
-                    <a:lstStyle/>
-                    <a:p>
-                      <a:pPr indent="0" marL="0">
-                        <a:buNone/>
-                      </a:pPr>
-                      <a:r>
-                        <a:rPr lang="en-US" sz="1200" dirty="0">
-                          <a:solidFill>
-                            <a:srgbClr val="212121"/>
-                          </a:solidFill>
-                          <a:latin typeface="Calibri" pitchFamily="34" charset="0"/>
-                          <a:ea typeface="Calibri" pitchFamily="34" charset="-122"/>
-                          <a:cs typeface="Calibri" pitchFamily="34" charset="-120"/>
-                        </a:rPr>
-                        <a:t>Limited</a:t>
-                      </a:r>
-                      <a:endParaRPr lang="en-US" sz="1200" dirty="0">
-                        <a:latin typeface="Calibri" charset="0"/>
-                        <a:ea typeface="Calibri" charset="0"/>
-                        <a:cs typeface="Calibri" charset="0"/>
-                      </a:endParaRPr>
-                    </a:p>
-                  </a:txBody>
-                  <a:tcPr marL="91440" marR="91440" marT="45720" marB="45720" anchor="ctr">
-                    <a:lnL w="9525" cap="flat" cmpd="sng" algn="ctr">
-                      <a:solidFill>
-                        <a:srgbClr val="D9D9D9"/>
-                      </a:solidFill>
-                      <a:prstDash val="solid"/>
-                      <a:round/>
-                      <a:headEnd type="none" w="med" len="med"/>
-                      <a:tailEnd type="none" w="med" len="med"/>
-                    </a:lnL>
-                    <a:lnR w="9525" cap="flat" cmpd="sng" algn="ctr">
-                      <a:solidFill>
-                        <a:srgbClr val="D9D9D9"/>
-                      </a:solidFill>
-                      <a:prstDash val="solid"/>
-                      <a:round/>
-                      <a:headEnd type="none" w="med" len="med"/>
-                      <a:tailEnd type="none" w="med" len="med"/>
-                    </a:lnR>
-                    <a:lnT w="9525" cap="flat" cmpd="sng" algn="ctr">
-                      <a:solidFill>
-                        <a:srgbClr val="D9D9D9"/>
-                      </a:solidFill>
-                      <a:prstDash val="solid"/>
-                      <a:round/>
-                      <a:headEnd type="none" w="med" len="med"/>
-                      <a:tailEnd type="none" w="med" len="med"/>
-                    </a:lnT>
-                    <a:lnB w="9525" cap="flat" cmpd="sng" algn="ctr">
-                      <a:solidFill>
-                        <a:srgbClr val="D9D9D9"/>
-                      </a:solidFill>
-                      <a:prstDash val="solid"/>
-                      <a:round/>
-                      <a:headEnd type="none" w="med" len="med"/>
-                      <a:tailEnd type="none" w="med" len="med"/>
-                    </a:lnB>
-                    <a:solidFill>
-                      <a:srgbClr val="F2F2F2"/>
-                    </a:solidFill>
                   </a:tcPr>
                 </a:tc>
               </a:tr>
@@ -8679,6 +8473,9 @@
                       <a:headEnd type="none" w="med" len="med"/>
                       <a:tailEnd type="none" w="med" len="med"/>
                     </a:lnB>
+                    <a:solidFill>
+                      <a:srgbClr val="F2F2F2"/>
+                    </a:solidFill>
                   </a:tcPr>
                 </a:tc>
                 <a:tc>
@@ -8698,7 +8495,145 @@
                           <a:ea typeface="Calibri" pitchFamily="34" charset="-122"/>
                           <a:cs typeface="Calibri" pitchFamily="34" charset="-120"/>
                         </a:rPr>
-                        <a:t>Claude review action — ours to configure</a:t>
+                        <a:t>Official action — prompt fully ours</a:t>
+                      </a:r>
+                      <a:endParaRPr lang="en-US" sz="1200" dirty="0">
+                        <a:latin typeface="Calibri" charset="0"/>
+                        <a:ea typeface="Calibri" charset="0"/>
+                        <a:cs typeface="Calibri" charset="0"/>
+                      </a:endParaRPr>
+                    </a:p>
+                  </a:txBody>
+                  <a:tcPr marL="91440" marR="91440" marT="45720" marB="45720" anchor="ctr">
+                    <a:lnL w="9525" cap="flat" cmpd="sng" algn="ctr">
+                      <a:solidFill>
+                        <a:srgbClr val="D9D9D9"/>
+                      </a:solidFill>
+                      <a:prstDash val="solid"/>
+                      <a:round/>
+                      <a:headEnd type="none" w="med" len="med"/>
+                      <a:tailEnd type="none" w="med" len="med"/>
+                    </a:lnL>
+                    <a:lnR w="9525" cap="flat" cmpd="sng" algn="ctr">
+                      <a:solidFill>
+                        <a:srgbClr val="D9D9D9"/>
+                      </a:solidFill>
+                      <a:prstDash val="solid"/>
+                      <a:round/>
+                      <a:headEnd type="none" w="med" len="med"/>
+                      <a:tailEnd type="none" w="med" len="med"/>
+                    </a:lnR>
+                    <a:lnT w="9525" cap="flat" cmpd="sng" algn="ctr">
+                      <a:solidFill>
+                        <a:srgbClr val="D9D9D9"/>
+                      </a:solidFill>
+                      <a:prstDash val="solid"/>
+                      <a:round/>
+                      <a:headEnd type="none" w="med" len="med"/>
+                      <a:tailEnd type="none" w="med" len="med"/>
+                    </a:lnT>
+                    <a:lnB w="9525" cap="flat" cmpd="sng" algn="ctr">
+                      <a:solidFill>
+                        <a:srgbClr val="D9D9D9"/>
+                      </a:solidFill>
+                      <a:prstDash val="solid"/>
+                      <a:round/>
+                      <a:headEnd type="none" w="med" len="med"/>
+                      <a:tailEnd type="none" w="med" len="med"/>
+                    </a:lnB>
+                    <a:solidFill>
+                      <a:srgbClr val="F2F2F2"/>
+                    </a:solidFill>
+                  </a:tcPr>
+                </a:tc>
+                <a:tc>
+                  <a:txBody>
+                    <a:bodyPr/>
+                    <a:lstStyle/>
+                    <a:p>
+                      <a:pPr indent="0" marL="0">
+                        <a:buNone/>
+                      </a:pPr>
+                      <a:r>
+                        <a:rPr lang="en-US" sz="1200" dirty="0">
+                          <a:solidFill>
+                            <a:srgbClr val="212121"/>
+                          </a:solidFill>
+                          <a:latin typeface="Calibri" pitchFamily="34" charset="0"/>
+                          <a:ea typeface="Calibri" pitchFamily="34" charset="-122"/>
+                          <a:cs typeface="Calibri" pitchFamily="34" charset="-120"/>
+                        </a:rPr>
+                        <a:t>Bugbot (hosted) — less control</a:t>
+                      </a:r>
+                      <a:endParaRPr lang="en-US" sz="1200" dirty="0">
+                        <a:latin typeface="Calibri" charset="0"/>
+                        <a:ea typeface="Calibri" charset="0"/>
+                        <a:cs typeface="Calibri" charset="0"/>
+                      </a:endParaRPr>
+                    </a:p>
+                  </a:txBody>
+                  <a:tcPr marL="91440" marR="91440" marT="45720" marB="45720" anchor="ctr">
+                    <a:lnL w="9525" cap="flat" cmpd="sng" algn="ctr">
+                      <a:solidFill>
+                        <a:srgbClr val="D9D9D9"/>
+                      </a:solidFill>
+                      <a:prstDash val="solid"/>
+                      <a:round/>
+                      <a:headEnd type="none" w="med" len="med"/>
+                      <a:tailEnd type="none" w="med" len="med"/>
+                    </a:lnL>
+                    <a:lnR w="9525" cap="flat" cmpd="sng" algn="ctr">
+                      <a:solidFill>
+                        <a:srgbClr val="D9D9D9"/>
+                      </a:solidFill>
+                      <a:prstDash val="solid"/>
+                      <a:round/>
+                      <a:headEnd type="none" w="med" len="med"/>
+                      <a:tailEnd type="none" w="med" len="med"/>
+                    </a:lnR>
+                    <a:lnT w="9525" cap="flat" cmpd="sng" algn="ctr">
+                      <a:solidFill>
+                        <a:srgbClr val="D9D9D9"/>
+                      </a:solidFill>
+                      <a:prstDash val="solid"/>
+                      <a:round/>
+                      <a:headEnd type="none" w="med" len="med"/>
+                      <a:tailEnd type="none" w="med" len="med"/>
+                    </a:lnT>
+                    <a:lnB w="9525" cap="flat" cmpd="sng" algn="ctr">
+                      <a:solidFill>
+                        <a:srgbClr val="D9D9D9"/>
+                      </a:solidFill>
+                      <a:prstDash val="solid"/>
+                      <a:round/>
+                      <a:headEnd type="none" w="med" len="med"/>
+                      <a:tailEnd type="none" w="med" len="med"/>
+                    </a:lnB>
+                    <a:solidFill>
+                      <a:srgbClr val="F2F2F2"/>
+                    </a:solidFill>
+                  </a:tcPr>
+                </a:tc>
+              </a:tr>
+              <a:tr h="411480">
+                <a:tc>
+                  <a:txBody>
+                    <a:bodyPr/>
+                    <a:lstStyle/>
+                    <a:p>
+                      <a:pPr indent="0" marL="0">
+                        <a:buNone/>
+                      </a:pPr>
+                      <a:r>
+                        <a:rPr lang="en-US" sz="1200" dirty="0">
+                          <a:solidFill>
+                            <a:srgbClr val="212121"/>
+                          </a:solidFill>
+                          <a:latin typeface="Calibri" pitchFamily="34" charset="0"/>
+                          <a:ea typeface="Calibri" pitchFamily="34" charset="-122"/>
+                          <a:cs typeface="Calibri" pitchFamily="34" charset="-120"/>
+                        </a:rPr>
+                        <a:t>Automation economics</a:t>
                       </a:r>
                       <a:endParaRPr lang="en-US" sz="1200" dirty="0">
                         <a:latin typeface="Calibri" charset="0"/>
@@ -8763,7 +8698,72 @@
                           <a:ea typeface="Calibri" pitchFamily="34" charset="-122"/>
                           <a:cs typeface="Calibri" pitchFamily="34" charset="-120"/>
                         </a:rPr>
-                        <a:t>Bugbot — hosted service</a:t>
+                        <a:t>~5.5x fewer tokens per task; per-pipeline API billing, batch −50%</a:t>
+                      </a:r>
+                      <a:endParaRPr lang="en-US" sz="1200" dirty="0">
+                        <a:latin typeface="Calibri" charset="0"/>
+                        <a:ea typeface="Calibri" charset="0"/>
+                        <a:cs typeface="Calibri" charset="0"/>
+                      </a:endParaRPr>
+                    </a:p>
+                  </a:txBody>
+                  <a:tcPr marL="91440" marR="91440" marT="45720" marB="45720" anchor="ctr">
+                    <a:lnL w="9525" cap="flat" cmpd="sng" algn="ctr">
+                      <a:solidFill>
+                        <a:srgbClr val="D9D9D9"/>
+                      </a:solidFill>
+                      <a:prstDash val="solid"/>
+                      <a:round/>
+                      <a:headEnd type="none" w="med" len="med"/>
+                      <a:tailEnd type="none" w="med" len="med"/>
+                    </a:lnL>
+                    <a:lnR w="9525" cap="flat" cmpd="sng" algn="ctr">
+                      <a:solidFill>
+                        <a:srgbClr val="D9D9D9"/>
+                      </a:solidFill>
+                      <a:prstDash val="solid"/>
+                      <a:round/>
+                      <a:headEnd type="none" w="med" len="med"/>
+                      <a:tailEnd type="none" w="med" len="med"/>
+                    </a:lnR>
+                    <a:lnT w="9525" cap="flat" cmpd="sng" algn="ctr">
+                      <a:solidFill>
+                        <a:srgbClr val="D9D9D9"/>
+                      </a:solidFill>
+                      <a:prstDash val="solid"/>
+                      <a:round/>
+                      <a:headEnd type="none" w="med" len="med"/>
+                      <a:tailEnd type="none" w="med" len="med"/>
+                    </a:lnT>
+                    <a:lnB w="9525" cap="flat" cmpd="sng" algn="ctr">
+                      <a:solidFill>
+                        <a:srgbClr val="D9D9D9"/>
+                      </a:solidFill>
+                      <a:prstDash val="solid"/>
+                      <a:round/>
+                      <a:headEnd type="none" w="med" len="med"/>
+                      <a:tailEnd type="none" w="med" len="med"/>
+                    </a:lnB>
+                  </a:tcPr>
+                </a:tc>
+                <a:tc>
+                  <a:txBody>
+                    <a:bodyPr/>
+                    <a:lstStyle/>
+                    <a:p>
+                      <a:pPr indent="0" marL="0">
+                        <a:buNone/>
+                      </a:pPr>
+                      <a:r>
+                        <a:rPr lang="en-US" sz="1200" dirty="0">
+                          <a:solidFill>
+                            <a:srgbClr val="212121"/>
+                          </a:solidFill>
+                          <a:latin typeface="Calibri" pitchFamily="34" charset="0"/>
+                          <a:ea typeface="Calibri" pitchFamily="34" charset="-122"/>
+                          <a:cs typeface="Calibri" pitchFamily="34" charset="-120"/>
+                        </a:rPr>
+                        <a:t>Credit-based — heavy models drain credits</a:t>
                       </a:r>
                       <a:endParaRPr lang="en-US" sz="1200" dirty="0">
                         <a:latin typeface="Calibri" charset="0"/>
@@ -9055,7 +9055,7 @@
                 <a:ea typeface="Calibri" pitchFamily="34" charset="-122"/>
                 <a:cs typeface="Calibri" pitchFamily="34" charset="-120"/>
               </a:rPr>
-              <a:t>Complements, not competitors: Cursor in the editor, Claude in the automation — MCP integrations serve both.</a:t>
+              <a:t>Near feature parity in 2026 — the split is decided by economics, maturity, and our ready-built playbook. Cursor keeps the editor.</a:t>
             </a:r>
             <a:endParaRPr lang="en-US" sz="1600" dirty="0"/>
           </a:p>

</xml_diff>

<commit_message>
Slide 3 consistency fix: Cursor hooks acknowledged (newer, late 2025)
</commit_message>
<xml_diff>
--- a/slides/ai-first-development.pptx
+++ b/slides/ai-first-development.pptx
@@ -775,7 +775,7 @@
           <a:p>
             <a:r>
               <a:rPr lang="en-US" dirty="0"/>
-              <a:t>قبل ما أي agent يشتغل، في تجهيز بينركب مرة وحدة وبيعيش جوا الريبو: ذاكرة المشروع (CLAUDE.md أو .cursor/rules)، الصلاحيات وملفات التعديل المسموحة، وحراس الـ production اللي بيمنعوا قبل التنفيذ. الحراس الكاملين (hooks) ميزة Claude — Cursor ما إله مقابل كامل.</a:t>
+              <a:t>قبل ما أي agent يشتغل، في تجهيز بينركب مرة وحدة وبيعيش جوا الريبو: ذاكرة المشروع (CLAUDE.md أو .cursor/rules)، الصلاحيات وملفات التعديل المسموحة، وحراس الـ production اللي بيمنعوا قبل التنفيذ. الـ hooks موجودة عند الاثنين هلق — تبعت Claude أقدم وأنضج ومجربة عنا، وتبعت Cursor حديثة (أواخر 2025).</a:t>
             </a:r>
             <a:endParaRPr lang="en-US" dirty="0"/>
           </a:p>
@@ -3913,7 +3913,7 @@
                           <a:ea typeface="Calibri" pitchFamily="34" charset="-122"/>
                           <a:cs typeface="Calibri" pitchFamily="34" charset="-120"/>
                         </a:rPr>
-                        <a:t>Hooks — hard enforcement</a:t>
+                        <a:t>Hooks — GA, battle-tested</a:t>
                       </a:r>
                       <a:endParaRPr lang="en-US" sz="1300" dirty="0">
                         <a:latin typeface="Calibri" charset="0"/>
@@ -3978,7 +3978,7 @@
                           <a:ea typeface="Calibri" pitchFamily="34" charset="-122"/>
                           <a:cs typeface="Calibri" pitchFamily="34" charset="-120"/>
                         </a:rPr>
-                        <a:t>— no full equivalent</a:t>
+                        <a:t>Hooks — newer (late 2025)</a:t>
                       </a:r>
                       <a:endParaRPr lang="en-US" sz="1300" dirty="0">
                         <a:latin typeface="Calibri" charset="0"/>

</xml_diff>